<commit_message>
docs(ppt): v2 Team ID CMRU027, 40q bulk tier, 577 tests, deployed-only services note, live demo links with wake order
</commit_message>
<xml_diff>
--- a/Kisan360_SIH26132_Idea_PPT_v2.pptx
+++ b/Kisan360_SIH26132_Idea_PPT_v2.pptx
@@ -161,6 +161,50 @@
 </p:presentation>
 </file>
 
+<file path=ppt/changesInfos/changesInfo1.xml><?xml version="1.0" encoding="utf-8"?>
+<pc:chgInfo xmlns:a="http://schemas.openxmlformats.org/drawingml/2006/main" xmlns:r="http://schemas.openxmlformats.org/officeDocument/2006/relationships" xmlns:ac="http://schemas.microsoft.com/office/drawing/2013/main/command" xmlns:pc="http://schemas.microsoft.com/office/powerpoint/2013/main/command">
+  <pc:docChgLst>
+    <pc:chgData name="Rian Hussain" userId="0caf0c85c763a54f" providerId="LiveId" clId="{8250069A-2DCE-4DE8-9693-3915BBE1E914}"/>
+    <pc:docChg chg="undo custSel modSld">
+      <pc:chgData name="Rian Hussain" userId="0caf0c85c763a54f" providerId="LiveId" clId="{8250069A-2DCE-4DE8-9693-3915BBE1E914}" dt="2026-09-13T11:23:32.230" v="2" actId="1076"/>
+      <pc:docMkLst>
+        <pc:docMk/>
+      </pc:docMkLst>
+      <pc:sldChg chg="modSp mod">
+        <pc:chgData name="Rian Hussain" userId="0caf0c85c763a54f" providerId="LiveId" clId="{8250069A-2DCE-4DE8-9693-3915BBE1E914}" dt="2026-09-13T11:23:32.230" v="2" actId="1076"/>
+        <pc:sldMkLst>
+          <pc:docMk/>
+          <pc:sldMk cId="0" sldId="281"/>
+        </pc:sldMkLst>
+        <pc:spChg chg="mod">
+          <ac:chgData name="Rian Hussain" userId="0caf0c85c763a54f" providerId="LiveId" clId="{8250069A-2DCE-4DE8-9693-3915BBE1E914}" dt="2026-09-13T11:23:32.230" v="2" actId="1076"/>
+          <ac:spMkLst>
+            <pc:docMk/>
+            <pc:sldMk cId="0" sldId="281"/>
+            <ac:spMk id="15361" creationId="{00000000-0000-0000-0000-000000000000}"/>
+          </ac:spMkLst>
+        </pc:spChg>
+      </pc:sldChg>
+      <pc:sldChg chg="modSp mod">
+        <pc:chgData name="Rian Hussain" userId="0caf0c85c763a54f" providerId="LiveId" clId="{8250069A-2DCE-4DE8-9693-3915BBE1E914}" dt="2026-09-13T11:22:53.744" v="1" actId="20577"/>
+        <pc:sldMkLst>
+          <pc:docMk/>
+          <pc:sldMk cId="0" sldId="290"/>
+        </pc:sldMkLst>
+        <pc:spChg chg="mod">
+          <ac:chgData name="Rian Hussain" userId="0caf0c85c763a54f" providerId="LiveId" clId="{8250069A-2DCE-4DE8-9693-3915BBE1E914}" dt="2026-09-13T11:22:53.744" v="1" actId="20577"/>
+          <ac:spMkLst>
+            <pc:docMk/>
+            <pc:sldMk cId="0" sldId="290"/>
+            <ac:spMk id="17428" creationId="{00000000-0000-0000-0000-000000000000}"/>
+          </ac:spMkLst>
+        </pc:spChg>
+      </pc:sldChg>
+    </pc:docChg>
+  </pc:docChgLst>
+</pc:chgInfo>
+</file>
+
 <file path=ppt/notesMasters/notesMaster1.xml><?xml version="1.0" encoding="utf-8"?>
 <p:notesMaster xmlns:a="http://schemas.openxmlformats.org/drawingml/2006/main" xmlns:r="http://schemas.openxmlformats.org/officeDocument/2006/relationships" xmlns:p="http://schemas.openxmlformats.org/presentationml/2006/main">
   <p:cSld>
@@ -261,7 +305,7 @@
             <a:fld id="{C4D5ADD5-2BBC-4A94-8F86-D9013941F742}" type="datetimeFigureOut">
               <a:rPr lang="en-US"/>
               <a:pPr/>
-              <a:t>9/12/2026</a:t>
+              <a:t>9/13/2026</a:t>
             </a:fld>
             <a:endParaRPr lang="en-US"/>
           </a:p>
@@ -1534,7 +1578,7 @@
           <a:p>
             <a:fld id="{E60792E3-D524-454C-8AFD-A91972900BCB}" type="datetime1">
               <a:rPr lang="en-US" smtClean="0"/>
-              <a:t>9/12/2026</a:t>
+              <a:t>9/13/2026</a:t>
             </a:fld>
             <a:endParaRPr lang="en-US"/>
           </a:p>
@@ -1716,7 +1760,7 @@
           <a:p>
             <a:fld id="{053C3A68-6922-42D3-8905-ECC2D82A3469}" type="datetime1">
               <a:rPr lang="en-US" smtClean="0"/>
-              <a:t>9/12/2026</a:t>
+              <a:t>9/13/2026</a:t>
             </a:fld>
             <a:endParaRPr lang="en-US"/>
           </a:p>
@@ -1908,7 +1952,7 @@
           <a:p>
             <a:fld id="{CB69E9F4-7604-4950-A8B2-8ACDEDB1506E}" type="datetime1">
               <a:rPr lang="en-US" smtClean="0"/>
-              <a:t>9/12/2026</a:t>
+              <a:t>9/13/2026</a:t>
             </a:fld>
             <a:endParaRPr lang="en-US"/>
           </a:p>
@@ -2090,7 +2134,7 @@
           <a:p>
             <a:fld id="{708B7524-32A2-4C20-A58C-BC3BAA1042FC}" type="datetime1">
               <a:rPr lang="en-US" smtClean="0"/>
-              <a:t>9/12/2026</a:t>
+              <a:t>9/13/2026</a:t>
             </a:fld>
             <a:endParaRPr lang="en-US"/>
           </a:p>
@@ -2349,7 +2393,7 @@
           <a:p>
             <a:fld id="{1E994447-D6B2-43BB-A877-57F1A267B999}" type="datetime1">
               <a:rPr lang="en-US" smtClean="0"/>
-              <a:t>9/12/2026</a:t>
+              <a:t>9/13/2026</a:t>
             </a:fld>
             <a:endParaRPr lang="en-US"/>
           </a:p>
@@ -2648,7 +2692,7 @@
           <a:p>
             <a:fld id="{68920E16-BD35-483C-AA6B-346FC7E46DEA}" type="datetime1">
               <a:rPr lang="en-US" smtClean="0"/>
-              <a:t>9/12/2026</a:t>
+              <a:t>9/13/2026</a:t>
             </a:fld>
             <a:endParaRPr lang="en-US"/>
           </a:p>
@@ -3081,7 +3125,7 @@
           <a:p>
             <a:fld id="{2FEAC6F8-5103-4FC0-A69E-5C6AE6469DA8}" type="datetime1">
               <a:rPr lang="en-US" smtClean="0"/>
-              <a:t>9/12/2026</a:t>
+              <a:t>9/13/2026</a:t>
             </a:fld>
             <a:endParaRPr lang="en-US"/>
           </a:p>
@@ -3212,7 +3256,7 @@
           <a:p>
             <a:fld id="{C60C6921-0627-4C8F-83D5-0CF936D2FFDD}" type="datetime1">
               <a:rPr lang="en-US" smtClean="0"/>
-              <a:t>9/12/2026</a:t>
+              <a:t>9/13/2026</a:t>
             </a:fld>
             <a:endParaRPr lang="en-US"/>
           </a:p>
@@ -3321,7 +3365,7 @@
           <a:p>
             <a:fld id="{2FF08AD7-8103-40F8-983C-E2BA6BB9CBE0}" type="datetime1">
               <a:rPr lang="en-US" smtClean="0"/>
-              <a:t>9/12/2026</a:t>
+              <a:t>9/13/2026</a:t>
             </a:fld>
             <a:endParaRPr lang="en-US"/>
           </a:p>
@@ -3610,7 +3654,7 @@
           <a:p>
             <a:fld id="{DF8C06B4-9380-4A4D-AF49-A3596E17DAF5}" type="datetime1">
               <a:rPr lang="en-US" smtClean="0"/>
-              <a:t>9/12/2026</a:t>
+              <a:t>9/13/2026</a:t>
             </a:fld>
             <a:endParaRPr lang="en-US"/>
           </a:p>
@@ -3879,7 +3923,7 @@
           <a:p>
             <a:fld id="{EF7FDEF1-C582-4E22-9E77-D68326471F28}" type="datetime1">
               <a:rPr lang="en-US" smtClean="0"/>
-              <a:t>9/12/2026</a:t>
+              <a:t>9/13/2026</a:t>
             </a:fld>
             <a:endParaRPr lang="en-US"/>
           </a:p>
@@ -4122,7 +4166,7 @@
           <a:p>
             <a:fld id="{780A9602-A9A9-453F-AEF1-37B5837E02CD}" type="datetime1">
               <a:rPr lang="en-US" smtClean="0"/>
-              <a:t>9/12/2026</a:t>
+              <a:t>9/13/2026</a:t>
             </a:fld>
             <a:endParaRPr lang="en-US"/>
           </a:p>
@@ -5692,7 +5736,7 @@
               <a:rPr sz="1500" dirty="0">
                 <a:latin typeface="Arial"/>
               </a:rPr>
-              <a:t>TBD (update from portal)</a:t>
+              <a:t>CMRU027</a:t>
             </a:r>
           </a:p>
           <a:p>
@@ -5712,6 +5756,43 @@
                 <a:latin typeface="Arial"/>
               </a:rPr>
               <a:t>Kisan360  |  CMR University</a:t>
+            </a:r>
+          </a:p>
+          <a:p>
+            <a:pPr>
+              <a:spcBef>
+                <a:spcPts val="600"/>
+              </a:spcBef>
+            </a:pPr>
+            <a:r>
+              <a:rPr sz="1200" b="1"/>
+              <a:t>Live demo — open in this order (free-tier services wake on first visit): </a:t>
+            </a:r>
+            <a:r>
+              <a:rPr sz="1100">
+                <a:hlinkClick r:id="rId5"/>
+              </a:rPr>
+              <a:t>1) calculator health</a:t>
+            </a:r>
+            <a:r>
+              <a:rPr sz="1100"/>
+              <a:t>  ·  </a:t>
+            </a:r>
+            <a:r>
+              <a:rPr sz="1100">
+                <a:hlinkClick r:id="rId6"/>
+              </a:rPr>
+              <a:t>2) API health</a:t>
+            </a:r>
+            <a:r>
+              <a:rPr sz="1100"/>
+              <a:t>  ·  </a:t>
+            </a:r>
+            <a:r>
+              <a:rPr sz="1100">
+                <a:hlinkClick r:id="rId7"/>
+              </a:rPr>
+              <a:t>3) the app</a:t>
             </a:r>
           </a:p>
         </p:txBody>
@@ -6428,7 +6509,7 @@
         </p:nvSpPr>
         <p:spPr>
           <a:xfrm>
-            <a:off x="182998" y="0"/>
+            <a:off x="162064" y="297498"/>
             <a:ext cx="10972800" cy="1143000"/>
           </a:xfrm>
         </p:spPr>
@@ -7693,7 +7774,7 @@
                 <a:latin typeface="Arial"/>
               </a:rPr>
               <a:t>FPO Pool
-50 q bulk</a:t>
+40 q bulk</a:t>
             </a:r>
           </a:p>
         </p:txBody>
@@ -7795,7 +7876,7 @@
               </a:spcAft>
             </a:pPr>
             <a:r>
-              <a:rPr sz="1900" b="1">
+              <a:rPr sz="1900" b="1" dirty="0">
                 <a:solidFill>
                   <a:srgbClr val="1F3864"/>
                 </a:solidFill>
@@ -7811,7 +7892,7 @@
               </a:spcAft>
             </a:pPr>
             <a:r>
-              <a:rPr sz="1200" b="0">
+              <a:rPr sz="1200" b="0" dirty="0">
                 <a:solidFill>
                   <a:srgbClr val="262626"/>
                 </a:solidFill>
@@ -7827,13 +7908,31 @@
               </a:spcAft>
             </a:pPr>
             <a:r>
-              <a:rPr sz="1200" b="0">
+              <a:rPr sz="1200" b="0" dirty="0">
                 <a:solidFill>
                   <a:srgbClr val="262626"/>
                 </a:solidFill>
                 <a:latin typeface="Arial"/>
               </a:rPr>
-              <a:t>Node/Express API — 22 routes; Python FastAPI: net-realization (:8002), disease CNN (:8000), advisory RAG (:8001).</a:t>
+              <a:t>Node/Express API — 22 routes; Python </a:t>
+            </a:r>
+            <a:r>
+              <a:rPr sz="1200" b="0" dirty="0" err="1">
+                <a:solidFill>
+                  <a:srgbClr val="262626"/>
+                </a:solidFill>
+                <a:latin typeface="Arial"/>
+              </a:rPr>
+              <a:t>FastAPI</a:t>
+            </a:r>
+            <a:r>
+              <a:rPr sz="1200" b="0" dirty="0">
+                <a:solidFill>
+                  <a:srgbClr val="262626"/>
+                </a:solidFill>
+                <a:latin typeface="Arial"/>
+              </a:rPr>
+              <a:t>: net-realization (:8002, deployed); disease + advisory degrade gracefully.</a:t>
             </a:r>
           </a:p>
           <a:p>
@@ -7843,13 +7942,31 @@
               </a:spcAft>
             </a:pPr>
             <a:r>
-              <a:rPr sz="1200" b="0">
+              <a:rPr sz="1200" b="0" dirty="0">
                 <a:solidFill>
                   <a:srgbClr val="262626"/>
                 </a:solidFill>
                 <a:latin typeface="Arial"/>
               </a:rPr>
-              <a:t>AGMARKNET live + stamped snapshot; MongoDB Atlas with memory fallback; Groq LLM explains only — never computes.</a:t>
+              <a:t>AGMARKNET live + stamped snapshot; MongoDB Atlas with memory fallback; </a:t>
+            </a:r>
+            <a:r>
+              <a:rPr sz="1200" b="0" dirty="0" err="1">
+                <a:solidFill>
+                  <a:srgbClr val="262626"/>
+                </a:solidFill>
+                <a:latin typeface="Arial"/>
+              </a:rPr>
+              <a:t>Groq</a:t>
+            </a:r>
+            <a:r>
+              <a:rPr sz="1200" b="0" dirty="0">
+                <a:solidFill>
+                  <a:srgbClr val="262626"/>
+                </a:solidFill>
+                <a:latin typeface="Arial"/>
+              </a:rPr>
+              <a:t> LLM explains only — never computes.</a:t>
             </a:r>
           </a:p>
           <a:p>
@@ -7859,13 +7976,13 @@
               </a:spcAft>
             </a:pPr>
             <a:r>
-              <a:rPr sz="1200" b="0">
+              <a:rPr sz="1200" b="0" dirty="0">
                 <a:solidFill>
                   <a:srgbClr val="262626"/>
                 </a:solidFill>
                 <a:latin typeface="Arial"/>
               </a:rPr>
-              <a:t>Quality bar: 575 tests green; one-command boot; TRL 6 prototype.</a:t>
+              <a:t>Quality bar: 577 tests green; one-command boot; TRL 6 prototype.</a:t>
             </a:r>
           </a:p>
         </p:txBody>

</xml_diff>